<commit_message>
Use the Quranic head-of-haa sukun (U+06E1) instead of the round sukun in madd and tanween decks
Co-Authored-By: Claude Opus 5.5 <noreply@anthropic.com>
Claude-Session: https://claude.ai/code/session_01XjTEwQ8YdBa1SjcPiYTm9z
</commit_message>
<xml_diff>
--- a/madd-plus/Quran-Small-Letters.pptx
+++ b/madd-plus/Quran-Small-Letters.pptx
@@ -1409,7 +1409,7 @@
           <a:p>
             <a:r>
               <a:rPr lang="en-US" dirty="0"/>
-              <a:t>لا صلة إذا جاء بعد الهاء ساكن: لا تُكتب الواو ولا الياء الصغيرة ولا تُنطق، مثل «لَهُ ٱلْمُلْكُ». أما «إِنَّهُۥ لَا يُحِبُّ» فتُنطق الواو لأن اللام بعدها متحركة.</a:t>
+              <a:t>لا صلة إذا جاء بعد الهاء ساكن: لا تُكتب الواو ولا الياء الصغيرة ولا تُنطق، مثل «لَهُ ٱلۡمُلۡكُ». أما «إِنَّهُۥ لَا يُحِبُّ» فتُنطق الواو لأن اللام بعدها متحركة.</a:t>
             </a:r>
             <a:endParaRPr lang="en-US" dirty="0"/>
           </a:p>
@@ -1761,7 +1761,7 @@
           <a:p>
             <a:r>
               <a:rPr lang="en-US" dirty="0"/>
-              <a:t>لا صلة إذا جاء بعد الهاء ساكن: لا تُكتب الواو ولا الياء الصغيرة ولا تُنطق، مثل «لَهُ ٱلْمُلْكُ». أما «إِنَّهُۥ لَا يُحِبُّ» فتُنطق الواو لأن اللام بعدها متحركة.</a:t>
+              <a:t>لا صلة إذا جاء بعد الهاء ساكن: لا تُكتب الواو ولا الياء الصغيرة ولا تُنطق، مثل «لَهُ ٱلۡمُلۡكُ». أما «إِنَّهُۥ لَا يُحِبُّ» فتُنطق الواو لأن اللام بعدها متحركة.</a:t>
             </a:r>
             <a:endParaRPr lang="en-US" dirty="0"/>
           </a:p>
@@ -1849,7 +1849,7 @@
           <a:p>
             <a:r>
               <a:rPr lang="en-US" dirty="0"/>
-              <a:t>لا صلة إذا جاء بعد الهاء ساكن: لا تُكتب الواو ولا الياء الصغيرة ولا تُنطق، مثل «لَهُ ٱلْمُلْكُ». أما «إِنَّهُۥ لَا يُحِبُّ» فتُنطق الواو لأن اللام بعدها متحركة.</a:t>
+              <a:t>لا صلة إذا جاء بعد الهاء ساكن: لا تُكتب الواو ولا الياء الصغيرة ولا تُنطق، مثل «لَهُ ٱلۡمُلۡكُ». أما «إِنَّهُۥ لَا يُحِبُّ» فتُنطق الواو لأن اللام بعدها متحركة.</a:t>
             </a:r>
             <a:endParaRPr lang="en-US" dirty="0"/>
           </a:p>
@@ -5094,7 +5094,7 @@
                 <a:ea typeface="Traditional Arabic" pitchFamily="34" charset="-122"/>
                 <a:cs typeface="Traditional Arabic" pitchFamily="34" charset="-120"/>
               </a:rPr>
-              <a:t>لَٰكِنْ</a:t>
+              <a:t>لَٰكِنۡ</a:t>
             </a:r>
             <a:endParaRPr lang="ar-SA" sz="7700" dirty="0"/>
           </a:p>
@@ -5158,7 +5158,7 @@
                 <a:ea typeface="Traditional Arabic" pitchFamily="34" charset="-122"/>
                 <a:cs typeface="Traditional Arabic" pitchFamily="34" charset="-120"/>
               </a:rPr>
-              <a:t>لَاكِنْ</a:t>
+              <a:t>لَاكِنۡ</a:t>
             </a:r>
             <a:endParaRPr lang="ar-SA" sz="7700" dirty="0"/>
           </a:p>
@@ -6917,7 +6917,7 @@
         </p:nvSpPr>
         <p:spPr>
           <a:xfrm>
-            <a:off x="5120640" y="1541953"/>
+            <a:off x="5120640" y="1530248"/>
             <a:ext cx="3566160" cy="2103120"/>
           </a:xfrm>
           <a:prstGeom prst="rect">
@@ -6934,7 +6934,7 @@
               <a:buNone/>
             </a:pPr>
             <a:r>
-              <a:rPr lang="ar-SA" altLang="en-US" sz="8300" dirty="0">
+              <a:rPr lang="ar-SA" altLang="en-US" sz="8400" dirty="0">
                 <a:solidFill>
                   <a:srgbClr val="16213E"/>
                 </a:solidFill>
@@ -6942,9 +6942,9 @@
                 <a:ea typeface="Traditional Arabic" pitchFamily="34" charset="-122"/>
                 <a:cs typeface="Traditional Arabic" pitchFamily="34" charset="-120"/>
               </a:rPr>
-              <a:t>ٱلْحَيَوٰةُ</a:t>
+              <a:t>ٱلۡحَيَوٰةُ</a:t>
             </a:r>
-            <a:endParaRPr lang="ar-SA" sz="8300" dirty="0"/>
+            <a:endParaRPr lang="ar-SA" sz="8400" dirty="0"/>
           </a:p>
         </p:txBody>
       </p:sp>
@@ -6981,7 +6981,7 @@
         </p:nvSpPr>
         <p:spPr>
           <a:xfrm>
-            <a:off x="457200" y="1570941"/>
+            <a:off x="457200" y="1559585"/>
             <a:ext cx="3566160" cy="2103120"/>
           </a:xfrm>
           <a:prstGeom prst="rect">
@@ -6998,7 +6998,7 @@
               <a:buNone/>
             </a:pPr>
             <a:r>
-              <a:rPr lang="ar-SA" altLang="en-US" sz="8300" dirty="0">
+              <a:rPr lang="ar-SA" altLang="en-US" sz="8400" dirty="0">
                 <a:solidFill>
                   <a:srgbClr val="16213E"/>
                 </a:solidFill>
@@ -7006,9 +7006,9 @@
                 <a:ea typeface="Traditional Arabic" pitchFamily="34" charset="-122"/>
                 <a:cs typeface="Traditional Arabic" pitchFamily="34" charset="-120"/>
               </a:rPr>
-              <a:t>الْحَيَاةُ</a:t>
+              <a:t>الۡحَيَاةُ</a:t>
             </a:r>
-            <a:endParaRPr lang="ar-SA" sz="8300" dirty="0"/>
+            <a:endParaRPr lang="ar-SA" sz="8400" dirty="0"/>
           </a:p>
         </p:txBody>
       </p:sp>
@@ -9027,7 +9027,7 @@
         </p:nvSpPr>
         <p:spPr>
           <a:xfrm>
-            <a:off x="5120640" y="1541953"/>
+            <a:off x="5120640" y="1530248"/>
             <a:ext cx="3566160" cy="2103120"/>
           </a:xfrm>
           <a:prstGeom prst="rect">
@@ -9044,7 +9044,7 @@
               <a:buNone/>
             </a:pPr>
             <a:r>
-              <a:rPr lang="ar-SA" altLang="en-US" sz="8300" dirty="0">
+              <a:rPr lang="ar-SA" altLang="en-US" sz="8400" dirty="0">
                 <a:solidFill>
                   <a:srgbClr val="16213E"/>
                 </a:solidFill>
@@ -9052,9 +9052,9 @@
                 <a:ea typeface="Traditional Arabic" pitchFamily="34" charset="-122"/>
                 <a:cs typeface="Traditional Arabic" pitchFamily="34" charset="-120"/>
               </a:rPr>
-              <a:t>ٱلْهُدَىٰ</a:t>
+              <a:t>ٱلۡهُدَىٰ</a:t>
             </a:r>
-            <a:endParaRPr lang="ar-SA" sz="8300" dirty="0"/>
+            <a:endParaRPr lang="ar-SA" sz="8400" dirty="0"/>
           </a:p>
         </p:txBody>
       </p:sp>
@@ -9091,7 +9091,7 @@
         </p:nvSpPr>
         <p:spPr>
           <a:xfrm>
-            <a:off x="457200" y="1541953"/>
+            <a:off x="457200" y="1530248"/>
             <a:ext cx="3566160" cy="2103120"/>
           </a:xfrm>
           <a:prstGeom prst="rect">
@@ -9108,7 +9108,7 @@
               <a:buNone/>
             </a:pPr>
             <a:r>
-              <a:rPr lang="ar-SA" altLang="en-US" sz="8300" dirty="0">
+              <a:rPr lang="ar-SA" altLang="en-US" sz="8400" dirty="0">
                 <a:solidFill>
                   <a:srgbClr val="16213E"/>
                 </a:solidFill>
@@ -9116,9 +9116,9 @@
                 <a:ea typeface="Traditional Arabic" pitchFamily="34" charset="-122"/>
                 <a:cs typeface="Traditional Arabic" pitchFamily="34" charset="-120"/>
               </a:rPr>
-              <a:t>الْهُدَا</a:t>
+              <a:t>الۡهُدَا</a:t>
             </a:r>
-            <a:endParaRPr lang="ar-SA" sz="8300" dirty="0"/>
+            <a:endParaRPr lang="ar-SA" sz="8400" dirty="0"/>
           </a:p>
         </p:txBody>
       </p:sp>
@@ -12117,7 +12117,7 @@
         </p:nvSpPr>
         <p:spPr>
           <a:xfrm>
-            <a:off x="5120640" y="1471249"/>
+            <a:off x="5120640" y="1464310"/>
             <a:ext cx="3566160" cy="2103120"/>
           </a:xfrm>
           <a:prstGeom prst="rect">
@@ -12134,7 +12134,7 @@
               <a:buNone/>
             </a:pPr>
             <a:r>
-              <a:rPr lang="ar-SA" altLang="en-US" sz="4500" dirty="0">
+              <a:rPr lang="ar-SA" altLang="en-US" sz="4000" dirty="0">
                 <a:solidFill>
                   <a:srgbClr val="16213E"/>
                 </a:solidFill>
@@ -12142,9 +12142,9 @@
                 <a:ea typeface="Traditional Arabic" pitchFamily="34" charset="-122"/>
                 <a:cs typeface="Traditional Arabic" pitchFamily="34" charset="-120"/>
               </a:rPr>
-              <a:t>وَقَلْبِهِۦ وَجَعَلَ</a:t>
+              <a:t>وَقَلۡبِهِۦ وَجَعَلَ</a:t>
             </a:r>
-            <a:endParaRPr lang="ar-SA" sz="4500" dirty="0"/>
+            <a:endParaRPr lang="ar-SA" sz="4000" dirty="0"/>
           </a:p>
         </p:txBody>
       </p:sp>
@@ -12181,7 +12181,7 @@
         </p:nvSpPr>
         <p:spPr>
           <a:xfrm>
-            <a:off x="457200" y="1453541"/>
+            <a:off x="457200" y="1448570"/>
             <a:ext cx="3566160" cy="2103120"/>
           </a:xfrm>
           <a:prstGeom prst="rect">
@@ -12198,7 +12198,7 @@
               <a:buNone/>
             </a:pPr>
             <a:r>
-              <a:rPr lang="ar-SA" altLang="en-US" sz="4500" dirty="0">
+              <a:rPr lang="ar-SA" altLang="en-US" sz="4000" dirty="0">
                 <a:solidFill>
                   <a:srgbClr val="16213E"/>
                 </a:solidFill>
@@ -12206,9 +12206,9 @@
                 <a:ea typeface="Traditional Arabic" pitchFamily="34" charset="-122"/>
                 <a:cs typeface="Traditional Arabic" pitchFamily="34" charset="-120"/>
               </a:rPr>
-              <a:t>وَقَلْبِهِي وَجَعَلَ</a:t>
+              <a:t>وَقَلۡبِهِي وَجَعَلَ</a:t>
             </a:r>
-            <a:endParaRPr lang="ar-SA" sz="4500" dirty="0"/>
+            <a:endParaRPr lang="ar-SA" sz="4000" dirty="0"/>
           </a:p>
         </p:txBody>
       </p:sp>
@@ -12908,7 +12908,7 @@
         </p:nvSpPr>
         <p:spPr>
           <a:xfrm>
-            <a:off x="5120640" y="1614052"/>
+            <a:off x="5120640" y="1522781"/>
             <a:ext cx="3566160" cy="2103120"/>
           </a:xfrm>
           <a:prstGeom prst="rect">
@@ -12925,7 +12925,7 @@
               <a:buNone/>
             </a:pPr>
             <a:r>
-              <a:rPr lang="ar-SA" altLang="en-US" sz="6800" dirty="0">
+              <a:rPr lang="ar-SA" altLang="en-US" sz="4800" dirty="0">
                 <a:solidFill>
                   <a:srgbClr val="16213E"/>
                 </a:solidFill>
@@ -12933,9 +12933,9 @@
                 <a:ea typeface="Traditional Arabic" pitchFamily="34" charset="-122"/>
                 <a:cs typeface="Traditional Arabic" pitchFamily="34" charset="-120"/>
               </a:rPr>
-              <a:t>لَهُ ٱلْمُلْكُ</a:t>
+              <a:t>لَهُ ٱلۡمُلۡكُ</a:t>
             </a:r>
-            <a:endParaRPr lang="ar-SA" sz="6800" dirty="0"/>
+            <a:endParaRPr lang="ar-SA" sz="4800" dirty="0"/>
           </a:p>
         </p:txBody>
       </p:sp>
@@ -12972,7 +12972,7 @@
         </p:nvSpPr>
         <p:spPr>
           <a:xfrm>
-            <a:off x="457200" y="1527692"/>
+            <a:off x="457200" y="1501445"/>
             <a:ext cx="3566160" cy="2103120"/>
           </a:xfrm>
           <a:prstGeom prst="rect">
@@ -12989,7 +12989,7 @@
               <a:buNone/>
             </a:pPr>
             <a:r>
-              <a:rPr lang="ar-SA" altLang="en-US" sz="6800" dirty="0">
+              <a:rPr lang="ar-SA" altLang="en-US" sz="4800" dirty="0">
                 <a:solidFill>
                   <a:srgbClr val="16213E"/>
                 </a:solidFill>
@@ -12997,9 +12997,9 @@
                 <a:ea typeface="Traditional Arabic" pitchFamily="34" charset="-122"/>
                 <a:cs typeface="Traditional Arabic" pitchFamily="34" charset="-120"/>
               </a:rPr>
-              <a:t>لَهُلْ مُلْكُ</a:t>
+              <a:t>لَهُلۡ مُلۡكُ</a:t>
             </a:r>
-            <a:endParaRPr lang="ar-SA" sz="6800" dirty="0"/>
+            <a:endParaRPr lang="ar-SA" sz="4800" dirty="0"/>
           </a:p>
         </p:txBody>
       </p:sp>
@@ -13626,7 +13626,7 @@
         </p:nvSpPr>
         <p:spPr>
           <a:xfrm>
-            <a:off x="5120640" y="1521037"/>
+            <a:off x="5120640" y="1499045"/>
             <a:ext cx="3566160" cy="2103120"/>
           </a:xfrm>
           <a:prstGeom prst="rect">
@@ -13643,7 +13643,7 @@
               <a:buNone/>
             </a:pPr>
             <a:r>
-              <a:rPr lang="ar-SA" altLang="en-US" sz="6100" dirty="0">
+              <a:rPr lang="ar-SA" altLang="en-US" sz="4500" dirty="0">
                 <a:solidFill>
                   <a:srgbClr val="16213E"/>
                 </a:solidFill>
@@ -13651,9 +13651,9 @@
                 <a:ea typeface="Traditional Arabic" pitchFamily="34" charset="-122"/>
                 <a:cs typeface="Traditional Arabic" pitchFamily="34" charset="-120"/>
               </a:rPr>
-              <a:t>وَلَهُ ٱلْحَمْدُ</a:t>
+              <a:t>وَلَهُ ٱلۡحَمۡدُ</a:t>
             </a:r>
-            <a:endParaRPr lang="ar-SA" sz="6100" dirty="0"/>
+            <a:endParaRPr lang="ar-SA" sz="4500" dirty="0"/>
           </a:p>
         </p:txBody>
       </p:sp>
@@ -13690,7 +13690,7 @@
         </p:nvSpPr>
         <p:spPr>
           <a:xfrm>
-            <a:off x="457200" y="1506423"/>
+            <a:off x="457200" y="1497901"/>
             <a:ext cx="3566160" cy="2103120"/>
           </a:xfrm>
           <a:prstGeom prst="rect">
@@ -13707,7 +13707,7 @@
               <a:buNone/>
             </a:pPr>
             <a:r>
-              <a:rPr lang="ar-SA" altLang="en-US" sz="6100" dirty="0">
+              <a:rPr lang="ar-SA" altLang="en-US" sz="4500" dirty="0">
                 <a:solidFill>
                   <a:srgbClr val="16213E"/>
                 </a:solidFill>
@@ -13715,9 +13715,9 @@
                 <a:ea typeface="Traditional Arabic" pitchFamily="34" charset="-122"/>
                 <a:cs typeface="Traditional Arabic" pitchFamily="34" charset="-120"/>
               </a:rPr>
-              <a:t>وَلَهُلْ حَمْدُ</a:t>
+              <a:t>وَلَهُلۡ حَمۡدُ</a:t>
             </a:r>
-            <a:endParaRPr lang="ar-SA" sz="6100" dirty="0"/>
+            <a:endParaRPr lang="ar-SA" sz="4500" dirty="0"/>
           </a:p>
         </p:txBody>
       </p:sp>
@@ -14217,7 +14217,7 @@
         </p:nvSpPr>
         <p:spPr>
           <a:xfrm>
-            <a:off x="5120640" y="1580235"/>
+            <a:off x="5120640" y="1566918"/>
             <a:ext cx="3566160" cy="2103120"/>
           </a:xfrm>
           <a:prstGeom prst="rect">
@@ -14234,7 +14234,7 @@
               <a:buNone/>
             </a:pPr>
             <a:r>
-              <a:rPr lang="ar-SA" altLang="en-US" sz="4400" dirty="0">
+              <a:rPr lang="ar-SA" altLang="en-US" sz="3900" dirty="0">
                 <a:solidFill>
                   <a:srgbClr val="16213E"/>
                 </a:solidFill>
@@ -14242,9 +14242,9 @@
                 <a:ea typeface="Traditional Arabic" pitchFamily="34" charset="-122"/>
                 <a:cs typeface="Traditional Arabic" pitchFamily="34" charset="-120"/>
               </a:rPr>
-              <a:t>مَالَهُۥٓ أَخْلَدَهُۥ</a:t>
+              <a:t>مَالَهُۥٓ أَخۡلَدَهُۥ</a:t>
             </a:r>
-            <a:endParaRPr lang="ar-SA" sz="4400" dirty="0"/>
+            <a:endParaRPr lang="ar-SA" sz="3900" dirty="0"/>
           </a:p>
         </p:txBody>
       </p:sp>
@@ -14281,7 +14281,7 @@
         </p:nvSpPr>
         <p:spPr>
           <a:xfrm>
-            <a:off x="457200" y="1518767"/>
+            <a:off x="457200" y="1512435"/>
             <a:ext cx="3566160" cy="2103120"/>
           </a:xfrm>
           <a:prstGeom prst="rect">
@@ -14298,7 +14298,7 @@
               <a:buNone/>
             </a:pPr>
             <a:r>
-              <a:rPr lang="ar-SA" altLang="en-US" sz="4400" dirty="0">
+              <a:rPr lang="ar-SA" altLang="en-US" sz="3900" dirty="0">
                 <a:solidFill>
                   <a:srgbClr val="16213E"/>
                 </a:solidFill>
@@ -14306,9 +14306,9 @@
                 <a:ea typeface="Traditional Arabic" pitchFamily="34" charset="-122"/>
                 <a:cs typeface="Traditional Arabic" pitchFamily="34" charset="-120"/>
               </a:rPr>
-              <a:t>مَالَهُووو أَخْلَدَهُ</a:t>
+              <a:t>مَالَهُووو أَخۡلَدَهُ</a:t>
             </a:r>
-            <a:endParaRPr lang="ar-SA" sz="4400" dirty="0"/>
+            <a:endParaRPr lang="ar-SA" sz="3900" dirty="0"/>
           </a:p>
         </p:txBody>
       </p:sp>
@@ -14833,7 +14833,7 @@
         </p:nvSpPr>
         <p:spPr>
           <a:xfrm>
-            <a:off x="5120640" y="1482469"/>
+            <a:off x="5120640" y="1480476"/>
             <a:ext cx="3566160" cy="2103120"/>
           </a:xfrm>
           <a:prstGeom prst="rect">
@@ -14850,7 +14850,7 @@
               <a:buNone/>
             </a:pPr>
             <a:r>
-              <a:rPr lang="ar-SA" altLang="en-US" sz="3900" dirty="0">
+              <a:rPr lang="ar-SA" altLang="en-US" sz="3500" dirty="0">
                 <a:solidFill>
                   <a:srgbClr val="16213E"/>
                 </a:solidFill>
@@ -14860,7 +14860,7 @@
               </a:rPr>
               <a:t>بِهِۦٓ أَن يُوصَلَ</a:t>
             </a:r>
-            <a:endParaRPr lang="ar-SA" sz="3900" dirty="0"/>
+            <a:endParaRPr lang="ar-SA" sz="3500" dirty="0"/>
           </a:p>
         </p:txBody>
       </p:sp>
@@ -14897,7 +14897,7 @@
         </p:nvSpPr>
         <p:spPr>
           <a:xfrm>
-            <a:off x="457200" y="1467122"/>
+            <a:off x="457200" y="1466704"/>
             <a:ext cx="3566160" cy="2103120"/>
           </a:xfrm>
           <a:prstGeom prst="rect">
@@ -14914,7 +14914,7 @@
               <a:buNone/>
             </a:pPr>
             <a:r>
-              <a:rPr lang="ar-SA" altLang="en-US" sz="3900" dirty="0">
+              <a:rPr lang="ar-SA" altLang="en-US" sz="3500" dirty="0">
                 <a:solidFill>
                   <a:srgbClr val="16213E"/>
                 </a:solidFill>
@@ -14922,9 +14922,9 @@
                 <a:ea typeface="Traditional Arabic" pitchFamily="34" charset="-122"/>
                 <a:cs typeface="Traditional Arabic" pitchFamily="34" charset="-120"/>
               </a:rPr>
-              <a:t>بِهِييي أَنْ يُوصَلَ</a:t>
+              <a:t>بِهِييي أَنۡ يُوصَلَ</a:t>
             </a:r>
-            <a:endParaRPr lang="ar-SA" sz="3900" dirty="0"/>
+            <a:endParaRPr lang="ar-SA" sz="3500" dirty="0"/>
           </a:p>
         </p:txBody>
       </p:sp>
@@ -16075,7 +16075,7 @@
         </p:nvSpPr>
         <p:spPr>
           <a:xfrm>
-            <a:off x="5120640" y="1507974"/>
+            <a:off x="5120640" y="1497989"/>
             <a:ext cx="3566160" cy="2103120"/>
           </a:xfrm>
           <a:prstGeom prst="rect">
@@ -16092,7 +16092,7 @@
               <a:buNone/>
             </a:pPr>
             <a:r>
-              <a:rPr lang="ar-SA" altLang="en-US" sz="7200" dirty="0">
+              <a:rPr lang="ar-SA" altLang="en-US" sz="5600" dirty="0">
                 <a:solidFill>
                   <a:srgbClr val="16213E"/>
                 </a:solidFill>
@@ -16100,9 +16100,9 @@
                 <a:ea typeface="Traditional Arabic" pitchFamily="34" charset="-122"/>
                 <a:cs typeface="Traditional Arabic" pitchFamily="34" charset="-120"/>
               </a:rPr>
-              <a:t>هَٰٓأَنتُمْ</a:t>
+              <a:t>هَٰٓأَنتُمۡ</a:t>
             </a:r>
-            <a:endParaRPr lang="ar-SA" sz="7200" dirty="0"/>
+            <a:endParaRPr lang="ar-SA" sz="5600" dirty="0"/>
           </a:p>
         </p:txBody>
       </p:sp>
@@ -16139,7 +16139,7 @@
         </p:nvSpPr>
         <p:spPr>
           <a:xfrm>
-            <a:off x="457200" y="1485650"/>
+            <a:off x="457200" y="1480626"/>
             <a:ext cx="3566160" cy="2103120"/>
           </a:xfrm>
           <a:prstGeom prst="rect">
@@ -16156,7 +16156,7 @@
               <a:buNone/>
             </a:pPr>
             <a:r>
-              <a:rPr lang="ar-SA" altLang="en-US" sz="7200" dirty="0">
+              <a:rPr lang="ar-SA" altLang="en-US" sz="5600" dirty="0">
                 <a:solidFill>
                   <a:srgbClr val="16213E"/>
                 </a:solidFill>
@@ -16164,9 +16164,9 @@
                 <a:ea typeface="Traditional Arabic" pitchFamily="34" charset="-122"/>
                 <a:cs typeface="Traditional Arabic" pitchFamily="34" charset="-120"/>
               </a:rPr>
-              <a:t>هَااا أَنْتُمْ</a:t>
+              <a:t>هَااا أَنۡتُمۡ</a:t>
             </a:r>
-            <a:endParaRPr lang="ar-SA" sz="7200" dirty="0"/>
+            <a:endParaRPr lang="ar-SA" sz="5600" dirty="0"/>
           </a:p>
         </p:txBody>
       </p:sp>
@@ -20824,7 +20824,7 @@
         </p:nvSpPr>
         <p:spPr>
           <a:xfrm>
-            <a:off x="5120640" y="1359709"/>
+            <a:off x="5120640" y="1377619"/>
             <a:ext cx="3566160" cy="2103120"/>
           </a:xfrm>
           <a:prstGeom prst="rect">
@@ -20841,7 +20841,7 @@
               <a:buNone/>
             </a:pPr>
             <a:r>
-              <a:rPr lang="ar-SA" altLang="en-US" sz="7500" dirty="0">
+              <a:rPr lang="ar-SA" altLang="en-US" sz="6200" dirty="0">
                 <a:solidFill>
                   <a:srgbClr val="16213E"/>
                 </a:solidFill>
@@ -20849,9 +20849,9 @@
                 <a:ea typeface="Traditional Arabic" pitchFamily="34" charset="-122"/>
                 <a:cs typeface="Traditional Arabic" pitchFamily="34" charset="-120"/>
               </a:rPr>
-              <a:t>ٱلرَّحْمَٰنِ</a:t>
+              <a:t>ٱلرَّحۡمَٰنِ</a:t>
             </a:r>
-            <a:endParaRPr lang="ar-SA" sz="7500" dirty="0"/>
+            <a:endParaRPr lang="ar-SA" sz="6200" dirty="0"/>
           </a:p>
         </p:txBody>
       </p:sp>
@@ -20888,7 +20888,7 @@
         </p:nvSpPr>
         <p:spPr>
           <a:xfrm>
-            <a:off x="457200" y="1325404"/>
+            <a:off x="457200" y="1349261"/>
             <a:ext cx="3566160" cy="2103120"/>
           </a:xfrm>
           <a:prstGeom prst="rect">
@@ -20905,7 +20905,7 @@
               <a:buNone/>
             </a:pPr>
             <a:r>
-              <a:rPr lang="ar-SA" altLang="en-US" sz="7500" dirty="0">
+              <a:rPr lang="ar-SA" altLang="en-US" sz="6200" dirty="0">
                 <a:solidFill>
                   <a:srgbClr val="16213E"/>
                 </a:solidFill>
@@ -20913,9 +20913,9 @@
                 <a:ea typeface="Traditional Arabic" pitchFamily="34" charset="-122"/>
                 <a:cs typeface="Traditional Arabic" pitchFamily="34" charset="-120"/>
               </a:rPr>
-              <a:t>الرَّحْمَانِ</a:t>
+              <a:t>الرَّحۡمَانِ</a:t>
             </a:r>
-            <a:endParaRPr lang="ar-SA" sz="7500" dirty="0"/>
+            <a:endParaRPr lang="ar-SA" sz="6200" dirty="0"/>
           </a:p>
         </p:txBody>
       </p:sp>

</xml_diff>